<commit_message>
update gitflow for 2026
</commit_message>
<xml_diff>
--- a/Day1/gitflow.pptx
+++ b/Day1/gitflow.pptx
@@ -27,22 +27,6 @@
   </p:sldIdLst>
   <p:sldSz cx="24384000" cy="13716000"/>
   <p:notesSz cx="6858000" cy="9144000"/>
-  <p:embeddedFontLst>
-    <p:embeddedFont>
-      <p:font typeface="Helvetica Neue" panose="02000503000000020004" pitchFamily="2" charset="0"/>
-      <p:regular r:id="rId19"/>
-      <p:bold r:id="rId20"/>
-      <p:italic r:id="rId21"/>
-      <p:boldItalic r:id="rId22"/>
-    </p:embeddedFont>
-    <p:embeddedFont>
-      <p:font typeface="Helvetica Neue Light" panose="02000403000000020004" pitchFamily="2" charset="0"/>
-      <p:regular r:id="rId23"/>
-      <p:bold r:id="rId24"/>
-      <p:italic r:id="rId25"/>
-      <p:boldItalic r:id="rId26"/>
-    </p:embeddedFont>
-  </p:embeddedFontLst>
   <p:defaultTextStyle>
     <a:defPPr marR="0" lvl="0" algn="l" rtl="0">
       <a:lnSpc>
@@ -277,7 +261,7 @@
       <p15:sldGuideLst xmlns:p15="http://schemas.microsoft.com/office/powerpoint/2012/main"/>
     </p:ext>
     <p:ext uri="http://customooxmlschemas.google.com/">
-      <go:slidesCustomData xmlns:go="http://customooxmlschemas.google.com/" xmlns:ahyp="http://schemas.microsoft.com/office/drawing/2018/hyperlinkcolor" xmlns:p15="http://schemas.microsoft.com/office/powerpoint/2012/main" xmlns:p14="http://schemas.microsoft.com/office/powerpoint/2010/main" xmlns:com="http://schemas.openxmlformats.org/drawingml/2006/compatibility" xmlns:pvml="urn:schemas-microsoft-com:office:powerpoint" xmlns:v="urn:schemas-microsoft-com:vml" xmlns:o="urn:schemas-microsoft-com:office:office" xmlns:dgm="http://schemas.openxmlformats.org/drawingml/2006/diagram" xmlns:c="http://schemas.openxmlformats.org/drawingml/2006/chart" xmlns:mv="urn:schemas-microsoft-com:mac:vml" xmlns:mc="http://schemas.openxmlformats.org/markup-compatibility/2006" xmlns="" r:id="rId33" roundtripDataSignature="AMtx7mhACr3GF+oaOhhGKWHfbSq2XX1c1g=="/>
+      <go:slidesCustomData xmlns="" xmlns:mc="http://schemas.openxmlformats.org/markup-compatibility/2006" xmlns:mv="urn:schemas-microsoft-com:mac:vml" xmlns:c="http://schemas.openxmlformats.org/drawingml/2006/chart" xmlns:dgm="http://schemas.openxmlformats.org/drawingml/2006/diagram" xmlns:o="urn:schemas-microsoft-com:office:office" xmlns:v="urn:schemas-microsoft-com:vml" xmlns:pvml="urn:schemas-microsoft-com:office:powerpoint" xmlns:com="http://schemas.openxmlformats.org/drawingml/2006/compatibility" xmlns:p14="http://schemas.microsoft.com/office/powerpoint/2010/main" xmlns:p15="http://schemas.microsoft.com/office/powerpoint/2012/main" xmlns:ahyp="http://schemas.microsoft.com/office/drawing/2018/hyperlinkcolor" xmlns:go="http://customooxmlschemas.google.com/" r:id="rId33" roundtripDataSignature="AMtx7mhACr3GF+oaOhhGKWHfbSq2XX1c1g=="/>
     </p:ext>
   </p:extLst>
 </p:presentation>
@@ -4514,7 +4498,7 @@
           <a:p>
             <a:fld id="{34073DC1-AB27-4363-9845-555972D7C4F0}" type="datetimeFigureOut">
               <a:rPr lang="en-US" smtClean="0"/>
-              <a:t>8/4/25</a:t>
+              <a:t>5/31/26</a:t>
             </a:fld>
             <a:endParaRPr lang="en-US"/>
           </a:p>
@@ -10950,17 +10934,8 @@
               <a:rPr lang="en-US" dirty="0">
                 <a:latin typeface="+mn-lt"/>
               </a:rPr>
-              <a:t>Code/</a:t>
+              <a:t>Code/Astro 2026</a:t>
             </a:r>
-            <a:r>
-              <a:rPr lang="en-US">
-                <a:latin typeface="+mn-lt"/>
-              </a:rPr>
-              <a:t>Astro 2025</a:t>
-            </a:r>
-            <a:endParaRPr lang="en-US" dirty="0">
-              <a:latin typeface="+mn-lt"/>
-            </a:endParaRPr>
           </a:p>
         </p:txBody>
       </p:sp>
@@ -14929,7 +14904,7 @@
         </p:nvSpPr>
         <p:spPr>
           <a:xfrm>
-            <a:off x="5215581" y="5910629"/>
+            <a:off x="4780925" y="3163107"/>
             <a:ext cx="14920110" cy="1200329"/>
           </a:xfrm>
           <a:prstGeom prst="rect">
@@ -14964,7 +14939,7 @@
         </p:nvSpPr>
         <p:spPr>
           <a:xfrm>
-            <a:off x="7111067" y="7289800"/>
+            <a:off x="4781492" y="4573440"/>
             <a:ext cx="14131158" cy="1200329"/>
           </a:xfrm>
           <a:prstGeom prst="rect">
@@ -14999,7 +14974,7 @@
         </p:nvSpPr>
         <p:spPr>
           <a:xfrm>
-            <a:off x="3141775" y="11158993"/>
+            <a:off x="6204499" y="5806850"/>
             <a:ext cx="13815848" cy="1200329"/>
           </a:xfrm>
           <a:prstGeom prst="rect">
@@ -15034,7 +15009,7 @@
         </p:nvSpPr>
         <p:spPr>
           <a:xfrm>
-            <a:off x="3673796" y="8369008"/>
+            <a:off x="7432996" y="7274441"/>
             <a:ext cx="14131158" cy="1200329"/>
           </a:xfrm>
           <a:prstGeom prst="rect">
@@ -15069,7 +15044,7 @@
         </p:nvSpPr>
         <p:spPr>
           <a:xfrm>
-            <a:off x="3673796" y="4740857"/>
+            <a:off x="4131741" y="10049744"/>
             <a:ext cx="17836772" cy="646331"/>
           </a:xfrm>
           <a:prstGeom prst="rect">
@@ -15104,7 +15079,7 @@
         </p:nvSpPr>
         <p:spPr>
           <a:xfrm>
-            <a:off x="2450131" y="3459605"/>
+            <a:off x="4160422" y="8816334"/>
             <a:ext cx="17836772" cy="646331"/>
           </a:xfrm>
           <a:prstGeom prst="rect">
@@ -15139,7 +15114,7 @@
         </p:nvSpPr>
         <p:spPr>
           <a:xfrm>
-            <a:off x="3673796" y="9764000"/>
+            <a:off x="3673796" y="11074400"/>
             <a:ext cx="16346551" cy="1200329"/>
           </a:xfrm>
           <a:prstGeom prst="rect">

</xml_diff>

<commit_message>
gitflow changes for 2026
</commit_message>
<xml_diff>
--- a/Day1/gitflow.pptx
+++ b/Day1/gitflow.pptx
@@ -22,8 +22,8 @@
     <p:sldId id="296" r:id="rId13"/>
     <p:sldId id="293" r:id="rId14"/>
     <p:sldId id="274" r:id="rId15"/>
-    <p:sldId id="291" r:id="rId16"/>
-    <p:sldId id="294" r:id="rId17"/>
+    <p:sldId id="294" r:id="rId16"/>
+    <p:sldId id="291" r:id="rId17"/>
   </p:sldIdLst>
   <p:sldSz cx="24384000" cy="13716000"/>
   <p:notesSz cx="6858000" cy="9144000"/>
@@ -261,7 +261,7 @@
       <p15:sldGuideLst xmlns:p15="http://schemas.microsoft.com/office/powerpoint/2012/main"/>
     </p:ext>
     <p:ext uri="http://customooxmlschemas.google.com/">
-      <go:slidesCustomData xmlns="" xmlns:mc="http://schemas.openxmlformats.org/markup-compatibility/2006" xmlns:mv="urn:schemas-microsoft-com:mac:vml" xmlns:c="http://schemas.openxmlformats.org/drawingml/2006/chart" xmlns:dgm="http://schemas.openxmlformats.org/drawingml/2006/diagram" xmlns:o="urn:schemas-microsoft-com:office:office" xmlns:v="urn:schemas-microsoft-com:vml" xmlns:pvml="urn:schemas-microsoft-com:office:powerpoint" xmlns:com="http://schemas.openxmlformats.org/drawingml/2006/compatibility" xmlns:p14="http://schemas.microsoft.com/office/powerpoint/2010/main" xmlns:p15="http://schemas.microsoft.com/office/powerpoint/2012/main" xmlns:ahyp="http://schemas.microsoft.com/office/drawing/2018/hyperlinkcolor" xmlns:go="http://customooxmlschemas.google.com/" r:id="rId33" roundtripDataSignature="AMtx7mhACr3GF+oaOhhGKWHfbSq2XX1c1g=="/>
+      <go:slidesCustomData xmlns:go="http://customooxmlschemas.google.com/" xmlns:ahyp="http://schemas.microsoft.com/office/drawing/2018/hyperlinkcolor" xmlns:p15="http://schemas.microsoft.com/office/powerpoint/2012/main" xmlns:p14="http://schemas.microsoft.com/office/powerpoint/2010/main" xmlns:com="http://schemas.openxmlformats.org/drawingml/2006/compatibility" xmlns:pvml="urn:schemas-microsoft-com:office:powerpoint" xmlns:v="urn:schemas-microsoft-com:vml" xmlns:o="urn:schemas-microsoft-com:office:office" xmlns:dgm="http://schemas.openxmlformats.org/drawingml/2006/diagram" xmlns:c="http://schemas.openxmlformats.org/drawingml/2006/chart" xmlns:mv="urn:schemas-microsoft-com:mac:vml" xmlns:mc="http://schemas.openxmlformats.org/markup-compatibility/2006" xmlns="" r:id="rId33" roundtripDataSignature="AMtx7mhACr3GF+oaOhhGKWHfbSq2XX1c1g=="/>
     </p:ext>
   </p:extLst>
 </p:presentation>
@@ -1517,7 +1517,7 @@
     </p:spTree>
     <p:extLst>
       <p:ext uri="{BB962C8B-B14F-4D97-AF65-F5344CB8AC3E}">
-        <p14:creationId xmlns:p14="http://schemas.microsoft.com/office/powerpoint/2010/main" val="1895333862"/>
+        <p14:creationId xmlns:p14="http://schemas.microsoft.com/office/powerpoint/2010/main" val="1796064178"/>
       </p:ext>
     </p:extLst>
   </p:cSld>
@@ -1626,7 +1626,7 @@
     </p:spTree>
     <p:extLst>
       <p:ext uri="{BB962C8B-B14F-4D97-AF65-F5344CB8AC3E}">
-        <p14:creationId xmlns:p14="http://schemas.microsoft.com/office/powerpoint/2010/main" val="1796064178"/>
+        <p14:creationId xmlns:p14="http://schemas.microsoft.com/office/powerpoint/2010/main" val="1895333862"/>
       </p:ext>
     </p:extLst>
   </p:cSld>
@@ -4498,7 +4498,7 @@
           <a:p>
             <a:fld id="{34073DC1-AB27-4363-9845-555972D7C4F0}" type="datetimeFigureOut">
               <a:rPr lang="en-US" smtClean="0"/>
-              <a:t>5/31/26</a:t>
+              <a:t>6/22/26</a:t>
             </a:fld>
             <a:endParaRPr lang="en-US"/>
           </a:p>
@@ -13448,7 +13448,7 @@
         </p:nvSpPr>
         <p:spPr>
           <a:xfrm>
-            <a:off x="1676400" y="730251"/>
+            <a:off x="533399" y="0"/>
             <a:ext cx="21031200" cy="2651126"/>
           </a:xfrm>
           <a:prstGeom prst="rect">
@@ -13475,14 +13475,10 @@
               <a:buSzPts val="4000"/>
             </a:pPr>
             <a:r>
-              <a:rPr lang="en-US" sz="8000" dirty="0"/>
-              <a:t>Some Relevant Git </a:t>
-            </a:r>
-            <a:r>
               <a:rPr lang="en-US" sz="8000" dirty="0">
                 <a:latin typeface="+mn-lt"/>
               </a:rPr>
-              <a:t>Commands</a:t>
+              <a:t>Activities [15 mins]</a:t>
             </a:r>
             <a:endParaRPr dirty="0">
               <a:latin typeface="+mn-lt"/>
@@ -13502,8 +13498,8 @@
         </p:nvSpPr>
         <p:spPr>
           <a:xfrm>
-            <a:off x="1676399" y="3226709"/>
-            <a:ext cx="22326601" cy="8702676"/>
+            <a:off x="533399" y="2055813"/>
+            <a:ext cx="10668001" cy="11660187"/>
           </a:xfrm>
           <a:prstGeom prst="rect">
             <a:avLst/>
@@ -13515,16 +13511,95 @@
         </p:spPr>
         <p:txBody>
           <a:bodyPr spcFirstLastPara="1" wrap="square" lIns="182850" tIns="91400" rIns="182850" bIns="91400" anchor="t" anchorCtr="0">
-            <a:normAutofit fontScale="92500" lnSpcReduction="10000"/>
+            <a:normAutofit fontScale="55000" lnSpcReduction="20000"/>
           </a:bodyPr>
           <a:lstStyle/>
           <a:p>
             <a:pPr marL="0" indent="0">
               <a:lnSpc>
-                <a:spcPct val="90000"/>
-              </a:lnSpc>
-              <a:spcBef>
-                <a:spcPts val="0"/>
+                <a:spcPct val="170000"/>
+              </a:lnSpc>
+              <a:spcBef>
+                <a:spcPts val="2000"/>
+              </a:spcBef>
+              <a:buClr>
+                <a:schemeClr val="dk1"/>
+              </a:buClr>
+              <a:buSzPct val="100000"/>
+              <a:buNone/>
+            </a:pPr>
+            <a:endParaRPr lang="en-US" dirty="0">
+              <a:latin typeface="Courier New"/>
+              <a:ea typeface="Courier New"/>
+              <a:cs typeface="Courier New"/>
+              <a:sym typeface="Courier New"/>
+            </a:endParaRPr>
+          </a:p>
+          <a:p>
+            <a:pPr marL="0" indent="0">
+              <a:lnSpc>
+                <a:spcPct val="120000"/>
+              </a:lnSpc>
+              <a:spcBef>
+                <a:spcPts val="2000"/>
+              </a:spcBef>
+              <a:buClr>
+                <a:schemeClr val="dk1"/>
+              </a:buClr>
+              <a:buSzPct val="100000"/>
+              <a:buNone/>
+            </a:pPr>
+            <a:r>
+              <a:rPr lang="en-US" dirty="0">
+                <a:latin typeface="+mn-lt"/>
+              </a:rPr>
+              <a:t>1. Make sure you can “git pull” the most recent version of the </a:t>
+            </a:r>
+            <a:r>
+              <a:rPr lang="en-US" dirty="0" err="1">
+                <a:latin typeface="+mn-lt"/>
+              </a:rPr>
+              <a:t>codeastro</a:t>
+            </a:r>
+            <a:r>
+              <a:rPr lang="en-US" dirty="0">
+                <a:latin typeface="+mn-lt"/>
+              </a:rPr>
+              <a:t> repo (main branch)</a:t>
+            </a:r>
+          </a:p>
+          <a:p>
+            <a:pPr marL="0" indent="0">
+              <a:lnSpc>
+                <a:spcPct val="120000"/>
+              </a:lnSpc>
+              <a:spcBef>
+                <a:spcPts val="2000"/>
+              </a:spcBef>
+              <a:buClr>
+                <a:schemeClr val="dk1"/>
+              </a:buClr>
+              <a:buSzPct val="100000"/>
+              <a:buNone/>
+            </a:pPr>
+            <a:r>
+              <a:rPr lang="en-US" dirty="0"/>
+              <a:t>	</a:t>
+            </a:r>
+            <a:r>
+              <a:rPr lang="en-US" sz="4400" dirty="0">
+                <a:latin typeface="+mn-lt"/>
+              </a:rPr>
+              <a:t>If you have local changes that you would like to save, you can do the following:</a:t>
+            </a:r>
+          </a:p>
+          <a:p>
+            <a:pPr marL="0" indent="0">
+              <a:lnSpc>
+                <a:spcPct val="120000"/>
+              </a:lnSpc>
+              <a:spcBef>
+                <a:spcPts val="2000"/>
               </a:spcBef>
               <a:buClr>
                 <a:schemeClr val="dk1"/>
@@ -13539,99 +13614,13 @@
                 <a:cs typeface="Courier New"/>
                 <a:sym typeface="Courier New"/>
               </a:rPr>
-              <a:t>&gt; git checkout –b &lt;</a:t>
+              <a:t>	$ git stash</a:t>
             </a:r>
-            <a:r>
-              <a:rPr lang="en-US" dirty="0" err="1">
-                <a:latin typeface="Courier New"/>
-                <a:ea typeface="Courier New"/>
-                <a:cs typeface="Courier New"/>
-                <a:sym typeface="Courier New"/>
-              </a:rPr>
-              <a:t>new_branch</a:t>
-            </a:r>
-            <a:r>
-              <a:rPr lang="en-US" dirty="0">
-                <a:latin typeface="Courier New"/>
-                <a:ea typeface="Courier New"/>
-                <a:cs typeface="Courier New"/>
-                <a:sym typeface="Courier New"/>
-              </a:rPr>
-              <a:t>&gt; &lt;</a:t>
-            </a:r>
-            <a:r>
-              <a:rPr lang="en-US" dirty="0" err="1">
-                <a:latin typeface="Courier New"/>
-                <a:ea typeface="Courier New"/>
-                <a:cs typeface="Courier New"/>
-                <a:sym typeface="Courier New"/>
-              </a:rPr>
-              <a:t>orig_branch</a:t>
-            </a:r>
-            <a:r>
-              <a:rPr lang="en-US" dirty="0">
-                <a:latin typeface="Courier New"/>
-                <a:ea typeface="Courier New"/>
-                <a:cs typeface="Courier New"/>
-                <a:sym typeface="Courier New"/>
-              </a:rPr>
-              <a:t>&gt; </a:t>
-            </a:r>
-            <a:endParaRPr lang="en-US" sz="4500" dirty="0"/>
           </a:p>
           <a:p>
             <a:pPr marL="0" indent="0">
               <a:lnSpc>
-                <a:spcPct val="90000"/>
-              </a:lnSpc>
-              <a:spcBef>
-                <a:spcPts val="2000"/>
-              </a:spcBef>
-              <a:buClr>
-                <a:schemeClr val="dk1"/>
-              </a:buClr>
-              <a:buSzPct val="100000"/>
-              <a:buNone/>
-            </a:pPr>
-            <a:r>
-              <a:rPr lang="en-US" sz="4500" dirty="0">
-                <a:latin typeface="+mn-lt"/>
-              </a:rPr>
-              <a:t>Make a new branch off of &lt;</a:t>
-            </a:r>
-            <a:r>
-              <a:rPr lang="en-US" sz="4500" dirty="0" err="1">
-                <a:latin typeface="+mn-lt"/>
-              </a:rPr>
-              <a:t>orig_branch</a:t>
-            </a:r>
-            <a:r>
-              <a:rPr lang="en-US" sz="4500" dirty="0">
-                <a:latin typeface="+mn-lt"/>
-              </a:rPr>
-              <a:t>&gt; (default: main)</a:t>
-            </a:r>
-          </a:p>
-          <a:p>
-            <a:pPr marL="0" indent="0">
-              <a:lnSpc>
-                <a:spcPct val="90000"/>
-              </a:lnSpc>
-              <a:spcBef>
-                <a:spcPts val="2000"/>
-              </a:spcBef>
-              <a:buClr>
-                <a:schemeClr val="dk1"/>
-              </a:buClr>
-              <a:buSzPct val="100000"/>
-              <a:buNone/>
-            </a:pPr>
-            <a:endParaRPr sz="4500" dirty="0"/>
-          </a:p>
-          <a:p>
-            <a:pPr marL="0" indent="0">
-              <a:lnSpc>
-                <a:spcPct val="90000"/>
+                <a:spcPct val="120000"/>
               </a:lnSpc>
               <a:spcBef>
                 <a:spcPts val="2000"/>
@@ -13649,50 +13638,13 @@
                 <a:cs typeface="Courier New"/>
                 <a:sym typeface="Courier New"/>
               </a:rPr>
-              <a:t>&gt; git checkout &lt;branch&gt;</a:t>
+              <a:t>	$ git pull origin main</a:t>
             </a:r>
           </a:p>
           <a:p>
             <a:pPr marL="0" indent="0">
               <a:lnSpc>
-                <a:spcPct val="90000"/>
-              </a:lnSpc>
-              <a:spcBef>
-                <a:spcPts val="2000"/>
-              </a:spcBef>
-              <a:buClr>
-                <a:schemeClr val="dk1"/>
-              </a:buClr>
-              <a:buSzPct val="100000"/>
-              <a:buNone/>
-            </a:pPr>
-            <a:r>
-              <a:rPr lang="en-US" sz="4500" dirty="0">
-                <a:latin typeface="+mn-lt"/>
-              </a:rPr>
-              <a:t>Switch to desired branch</a:t>
-            </a:r>
-          </a:p>
-          <a:p>
-            <a:pPr marL="0" indent="0">
-              <a:lnSpc>
-                <a:spcPct val="90000"/>
-              </a:lnSpc>
-              <a:spcBef>
-                <a:spcPts val="2000"/>
-              </a:spcBef>
-              <a:buClr>
-                <a:schemeClr val="dk1"/>
-              </a:buClr>
-              <a:buSzPct val="100000"/>
-              <a:buNone/>
-            </a:pPr>
-            <a:endParaRPr lang="en-US" sz="4500" dirty="0"/>
-          </a:p>
-          <a:p>
-            <a:pPr marL="0" indent="0">
-              <a:lnSpc>
-                <a:spcPct val="90000"/>
+                <a:spcPct val="120000"/>
               </a:lnSpc>
               <a:spcBef>
                 <a:spcPts val="2000"/>
@@ -13710,50 +13662,13 @@
                 <a:cs typeface="Courier New"/>
                 <a:sym typeface="Courier New"/>
               </a:rPr>
-              <a:t>&gt; git branch -a</a:t>
+              <a:t>	$ git stash pop</a:t>
             </a:r>
           </a:p>
           <a:p>
             <a:pPr marL="0" indent="0">
               <a:lnSpc>
-                <a:spcPct val="90000"/>
-              </a:lnSpc>
-              <a:spcBef>
-                <a:spcPts val="2000"/>
-              </a:spcBef>
-              <a:buClr>
-                <a:schemeClr val="dk1"/>
-              </a:buClr>
-              <a:buSzPct val="100000"/>
-              <a:buNone/>
-            </a:pPr>
-            <a:r>
-              <a:rPr lang="en-US" sz="4500" dirty="0">
-                <a:latin typeface="+mn-lt"/>
-              </a:rPr>
-              <a:t>List all available branches, highlighting the one you are currently on</a:t>
-            </a:r>
-          </a:p>
-          <a:p>
-            <a:pPr marL="0" indent="0">
-              <a:lnSpc>
-                <a:spcPct val="90000"/>
-              </a:lnSpc>
-              <a:spcBef>
-                <a:spcPts val="2000"/>
-              </a:spcBef>
-              <a:buClr>
-                <a:schemeClr val="dk1"/>
-              </a:buClr>
-              <a:buSzPct val="100000"/>
-              <a:buNone/>
-            </a:pPr>
-            <a:endParaRPr lang="en-US" sz="4500" dirty="0"/>
-          </a:p>
-          <a:p>
-            <a:pPr marL="0" indent="0">
-              <a:lnSpc>
-                <a:spcPct val="90000"/>
+                <a:spcPct val="120000"/>
               </a:lnSpc>
               <a:spcBef>
                 <a:spcPts val="2000"/>
@@ -13766,36 +13681,68 @@
             </a:pPr>
             <a:r>
               <a:rPr lang="en-US" dirty="0">
-                <a:latin typeface="Courier New"/>
+                <a:latin typeface="+mn-lt"/>
                 <a:ea typeface="Courier New"/>
                 <a:cs typeface="Courier New"/>
                 <a:sym typeface="Courier New"/>
               </a:rPr>
-              <a:t>&gt; git branch –d &lt;</a:t>
+              <a:t>2. Within your project groups, create a repository (either a dummy repo or a repo for your project), and do the following:</a:t>
             </a:r>
+          </a:p>
+          <a:p>
+            <a:pPr marL="685800" indent="-685800">
+              <a:lnSpc>
+                <a:spcPct val="120000"/>
+              </a:lnSpc>
+              <a:spcBef>
+                <a:spcPts val="2000"/>
+              </a:spcBef>
+              <a:buClr>
+                <a:schemeClr val="dk1"/>
+              </a:buClr>
+              <a:buSzPct val="100000"/>
+              <a:buFont typeface="Arial" panose="020B0604020202020204" pitchFamily="34" charset="0"/>
+              <a:buChar char="•"/>
+            </a:pPr>
             <a:r>
-              <a:rPr lang="en-US" dirty="0" err="1">
-                <a:latin typeface="Courier New"/>
+              <a:rPr lang="en-US" dirty="0">
+                <a:latin typeface="+mn-lt"/>
                 <a:ea typeface="Courier New"/>
                 <a:cs typeface="Courier New"/>
                 <a:sym typeface="Courier New"/>
               </a:rPr>
-              <a:t>branch_name</a:t>
+              <a:t>Create main, develop, and (at least) 2 feature branches.</a:t>
             </a:r>
+          </a:p>
+          <a:p>
+            <a:pPr marL="685800" indent="-685800">
+              <a:lnSpc>
+                <a:spcPct val="120000"/>
+              </a:lnSpc>
+              <a:spcBef>
+                <a:spcPts val="2000"/>
+              </a:spcBef>
+              <a:buClr>
+                <a:schemeClr val="dk1"/>
+              </a:buClr>
+              <a:buSzPct val="100000"/>
+              <a:buFont typeface="Arial" panose="020B0604020202020204" pitchFamily="34" charset="0"/>
+              <a:buChar char="•"/>
+            </a:pPr>
             <a:r>
               <a:rPr lang="en-US" dirty="0">
-                <a:latin typeface="Courier New"/>
+                <a:latin typeface="+mn-lt"/>
                 <a:ea typeface="Courier New"/>
                 <a:cs typeface="Courier New"/>
                 <a:sym typeface="Courier New"/>
               </a:rPr>
-              <a:t>&gt;</a:t>
+              <a:t>Raise an issue.</a:t>
             </a:r>
           </a:p>
           <a:p>
-            <a:pPr marL="0" indent="0">
-              <a:lnSpc>
-                <a:spcPct val="90000"/>
+            <a:pPr marL="685800" indent="-685800">
+              <a:lnSpc>
+                <a:spcPct val="120000"/>
               </a:lnSpc>
               <a:spcBef>
                 <a:spcPts val="2000"/>
@@ -13804,19 +13751,23 @@
                 <a:schemeClr val="dk1"/>
               </a:buClr>
               <a:buSzPct val="100000"/>
-              <a:buNone/>
+              <a:buFont typeface="Arial" panose="020B0604020202020204" pitchFamily="34" charset="0"/>
+              <a:buChar char="•"/>
             </a:pPr>
             <a:r>
-              <a:rPr lang="en-US" sz="4500" dirty="0">
+              <a:rPr lang="en-US" dirty="0">
                 <a:latin typeface="+mn-lt"/>
+                <a:ea typeface="Courier New"/>
+                <a:cs typeface="Courier New"/>
+                <a:sym typeface="Courier New"/>
               </a:rPr>
-              <a:t>Delete a branch from your local repo</a:t>
+              <a:t>Clone the repo to your machine, make changes on each of the feature branches, and open pull requests to merge them into main.</a:t>
             </a:r>
           </a:p>
           <a:p>
-            <a:pPr marL="0" indent="0">
-              <a:lnSpc>
-                <a:spcPct val="90000"/>
+            <a:pPr marL="685800" indent="-685800">
+              <a:lnSpc>
+                <a:spcPct val="120000"/>
               </a:lnSpc>
               <a:spcBef>
                 <a:spcPts val="2000"/>
@@ -13825,140 +13776,358 @@
                 <a:schemeClr val="dk1"/>
               </a:buClr>
               <a:buSzPct val="100000"/>
-              <a:buNone/>
+              <a:buFont typeface="Arial" panose="020B0604020202020204" pitchFamily="34" charset="0"/>
+              <a:buChar char="•"/>
             </a:pPr>
-            <a:endParaRPr lang="en-US" dirty="0">
-              <a:latin typeface="Courier New"/>
-              <a:ea typeface="Courier New"/>
-              <a:cs typeface="Courier New"/>
-              <a:sym typeface="Courier New"/>
-            </a:endParaRPr>
-          </a:p>
-          <a:p>
-            <a:pPr indent="-457200">
-              <a:lnSpc>
-                <a:spcPct val="90000"/>
-              </a:lnSpc>
-              <a:spcBef>
-                <a:spcPts val="2000"/>
-              </a:spcBef>
-              <a:buClr>
-                <a:schemeClr val="dk1"/>
-              </a:buClr>
-              <a:buSzPct val="100000"/>
-            </a:pPr>
-            <a:endParaRPr dirty="0"/>
-          </a:p>
-          <a:p>
-            <a:pPr marL="0" indent="0">
-              <a:lnSpc>
-                <a:spcPct val="90000"/>
-              </a:lnSpc>
-              <a:spcBef>
-                <a:spcPts val="2000"/>
-              </a:spcBef>
-              <a:buClr>
-                <a:schemeClr val="dk1"/>
-              </a:buClr>
-              <a:buSzPct val="100000"/>
-              <a:buNone/>
-            </a:pPr>
-            <a:endParaRPr dirty="0">
-              <a:latin typeface="Courier New"/>
-              <a:ea typeface="Courier New"/>
-              <a:cs typeface="Courier New"/>
-              <a:sym typeface="Courier New"/>
-            </a:endParaRPr>
+            <a:r>
+              <a:rPr lang="en-US" dirty="0">
+                <a:latin typeface="+mn-lt"/>
+                <a:ea typeface="Courier New"/>
+                <a:cs typeface="Courier New"/>
+                <a:sym typeface="Courier New"/>
+              </a:rPr>
+              <a:t>Perform the merges.</a:t>
+            </a:r>
           </a:p>
         </p:txBody>
       </p:sp>
       <p:sp>
         <p:nvSpPr>
-          <p:cNvPr id="99" name="Google Shape;99;p3"/>
+          <p:cNvPr id="3" name="TextBox 2">
+            <a:extLst>
+              <a:ext uri="{FF2B5EF4-FFF2-40B4-BE49-F238E27FC236}">
+                <a16:creationId xmlns:a16="http://schemas.microsoft.com/office/drawing/2014/main" id="{9372EDAA-967A-CDC7-83B8-26F0E18B2910}"/>
+              </a:ext>
+            </a:extLst>
+          </p:cNvPr>
           <p:cNvSpPr txBox="1"/>
           <p:nvPr/>
         </p:nvSpPr>
         <p:spPr>
           <a:xfrm>
-            <a:off x="0" y="12603390"/>
-            <a:ext cx="25117676" cy="1046360"/>
+            <a:off x="11963401" y="3154363"/>
+            <a:ext cx="11887200" cy="8098627"/>
           </a:xfrm>
           <a:prstGeom prst="rect">
             <a:avLst/>
           </a:prstGeom>
           <a:noFill/>
-          <a:ln>
-            <a:noFill/>
-          </a:ln>
         </p:spPr>
         <p:txBody>
-          <a:bodyPr spcFirstLastPara="1" wrap="square" lIns="182850" tIns="91400" rIns="182850" bIns="91400" anchor="t" anchorCtr="0">
+          <a:bodyPr wrap="square">
             <a:spAutoFit/>
           </a:bodyPr>
           <a:lstStyle/>
           <a:p>
-            <a:pPr algn="ctr"/>
+            <a:pPr marL="0" indent="0">
+              <a:lnSpc>
+                <a:spcPct val="90000"/>
+              </a:lnSpc>
+              <a:spcBef>
+                <a:spcPts val="2000"/>
+              </a:spcBef>
+              <a:buClr>
+                <a:schemeClr val="dk1"/>
+              </a:buClr>
+              <a:buSzPct val="100000"/>
+              <a:buNone/>
+            </a:pPr>
             <a:r>
-              <a:rPr lang="en-US" sz="3200" dirty="0">
-                <a:solidFill>
-                  <a:schemeClr val="dk1"/>
-                </a:solidFill>
+              <a:rPr lang="en-US" sz="3600" u="sng" dirty="0">
                 <a:latin typeface="+mn-lt"/>
-                <a:ea typeface="Calibri"/>
-                <a:cs typeface="Calibri"/>
-                <a:sym typeface="Calibri"/>
+                <a:ea typeface="Courier New"/>
+                <a:cs typeface="Courier New"/>
+                <a:sym typeface="Courier New"/>
               </a:rPr>
-              <a:t>There are a lot of “Git cheat sheets” online if you want a summary of more commands! Here’s the one I have bookmarked:</a:t>
+              <a:t>Helpful Tips</a:t>
             </a:r>
-          </a:p>
-          <a:p>
-            <a:pPr algn="ctr"/>
+            <a:r>
+              <a:rPr lang="en-US" sz="3600" dirty="0">
+                <a:latin typeface="+mn-lt"/>
+                <a:ea typeface="Courier New"/>
+                <a:cs typeface="Courier New"/>
+                <a:sym typeface="Courier New"/>
+              </a:rPr>
+              <a:t>:</a:t>
+            </a:r>
+          </a:p>
+          <a:p>
+            <a:pPr marL="0" indent="0">
+              <a:lnSpc>
+                <a:spcPct val="90000"/>
+              </a:lnSpc>
+              <a:spcBef>
+                <a:spcPts val="2000"/>
+              </a:spcBef>
+              <a:buClr>
+                <a:schemeClr val="dk1"/>
+              </a:buClr>
+              <a:buSzPct val="100000"/>
+              <a:buNone/>
+            </a:pPr>
+            <a:endParaRPr lang="en-US" sz="3600" dirty="0">
+              <a:latin typeface="+mn-lt"/>
+              <a:ea typeface="Courier New"/>
+              <a:cs typeface="Courier New"/>
+              <a:sym typeface="Courier New"/>
+            </a:endParaRPr>
+          </a:p>
+          <a:p>
+            <a:pPr marL="0" indent="0">
+              <a:lnSpc>
+                <a:spcPct val="90000"/>
+              </a:lnSpc>
+              <a:spcBef>
+                <a:spcPts val="2000"/>
+              </a:spcBef>
+              <a:buClr>
+                <a:schemeClr val="dk1"/>
+              </a:buClr>
+              <a:buSzPct val="100000"/>
+              <a:buNone/>
+            </a:pPr>
+            <a:r>
+              <a:rPr lang="en-US" sz="3600" dirty="0">
+                <a:latin typeface="+mn-lt"/>
+                <a:ea typeface="Courier New"/>
+                <a:cs typeface="Courier New"/>
+                <a:sym typeface="Courier New"/>
+              </a:rPr>
+              <a:t>1. If you are using git on your computer for the first time, you may need to run the following terminal commands:</a:t>
+            </a:r>
+          </a:p>
+          <a:p>
+            <a:pPr marL="0" indent="0">
+              <a:lnSpc>
+                <a:spcPct val="90000"/>
+              </a:lnSpc>
+              <a:spcBef>
+                <a:spcPts val="2000"/>
+              </a:spcBef>
+              <a:buClr>
+                <a:schemeClr val="dk1"/>
+              </a:buClr>
+              <a:buSzPct val="100000"/>
+              <a:buNone/>
+            </a:pPr>
+            <a:r>
+              <a:rPr lang="en-US" sz="3600" dirty="0">
+                <a:latin typeface="Courier New"/>
+                <a:cs typeface="Courier New"/>
+                <a:sym typeface="Courier New"/>
+              </a:rPr>
+              <a:t>	</a:t>
+            </a:r>
             <a:r>
               <a:rPr lang="en-US" sz="2400" dirty="0">
-                <a:latin typeface="+mn-lt"/>
+                <a:latin typeface="Courier New"/>
+                <a:cs typeface="Courier New"/>
+                <a:sym typeface="Courier New"/>
               </a:rPr>
-              <a:t>https://</a:t>
+              <a:t>$ git config --global </a:t>
             </a:r>
             <a:r>
               <a:rPr lang="en-US" sz="2400" dirty="0" err="1">
-                <a:latin typeface="+mn-lt"/>
+                <a:latin typeface="Courier New"/>
+                <a:cs typeface="Courier New"/>
+                <a:sym typeface="Courier New"/>
               </a:rPr>
-              <a:t>training.github.com</a:t>
+              <a:t>user.name</a:t>
             </a:r>
             <a:r>
               <a:rPr lang="en-US" sz="2400" dirty="0">
-                <a:latin typeface="+mn-lt"/>
+                <a:latin typeface="Courier New"/>
+                <a:cs typeface="Courier New"/>
+                <a:sym typeface="Courier New"/>
               </a:rPr>
-              <a:t>/downloads/</a:t>
+              <a:t> “Your Name”</a:t>
+            </a:r>
+          </a:p>
+          <a:p>
+            <a:pPr marL="0" indent="0">
+              <a:lnSpc>
+                <a:spcPct val="90000"/>
+              </a:lnSpc>
+              <a:spcBef>
+                <a:spcPts val="2000"/>
+              </a:spcBef>
+              <a:buClr>
+                <a:schemeClr val="dk1"/>
+              </a:buClr>
+              <a:buSzPct val="100000"/>
+              <a:buNone/>
+            </a:pPr>
+            <a:r>
+              <a:rPr lang="en-US" sz="2400" dirty="0">
+                <a:latin typeface="Courier New"/>
+                <a:cs typeface="Courier New"/>
+                <a:sym typeface="Courier New"/>
+              </a:rPr>
+              <a:t>	$ git config --global </a:t>
             </a:r>
             <a:r>
               <a:rPr lang="en-US" sz="2400" dirty="0" err="1">
-                <a:latin typeface="+mn-lt"/>
+                <a:latin typeface="Courier New"/>
+                <a:cs typeface="Courier New"/>
+                <a:sym typeface="Courier New"/>
               </a:rPr>
-              <a:t>github</a:t>
+              <a:t>user.email</a:t>
             </a:r>
             <a:r>
               <a:rPr lang="en-US" sz="2400" dirty="0">
-                <a:latin typeface="+mn-lt"/>
+                <a:latin typeface="Courier New"/>
+                <a:cs typeface="Courier New"/>
+                <a:sym typeface="Courier New"/>
               </a:rPr>
-              <a:t>-git-cheat-</a:t>
+              <a:t> “</a:t>
             </a:r>
             <a:r>
               <a:rPr lang="en-US" sz="2400" dirty="0" err="1">
-                <a:latin typeface="+mn-lt"/>
+                <a:latin typeface="Courier New"/>
+                <a:cs typeface="Courier New"/>
+                <a:sym typeface="Courier New"/>
               </a:rPr>
-              <a:t>sheet.pdf</a:t>
+              <a:t>your.email@example.com</a:t>
             </a:r>
-            <a:endParaRPr sz="2400" dirty="0">
-              <a:latin typeface="+mn-lt"/>
-            </a:endParaRPr>
+            <a:r>
+              <a:rPr lang="en-US" sz="2400" dirty="0">
+                <a:latin typeface="Courier New"/>
+                <a:cs typeface="Courier New"/>
+                <a:sym typeface="Courier New"/>
+              </a:rPr>
+              <a:t>”</a:t>
+            </a:r>
+          </a:p>
+          <a:p>
+            <a:pPr marL="0" indent="0">
+              <a:buNone/>
+            </a:pPr>
+            <a:r>
+              <a:rPr lang="en-US" sz="3600" dirty="0"/>
+              <a:t>2. To push to the same repository, the repository creator will need to add others as collaborators. To do this from the repo’s homepage:</a:t>
+            </a:r>
+          </a:p>
+          <a:p>
+            <a:pPr marL="0" indent="0">
+              <a:lnSpc>
+                <a:spcPct val="200000"/>
+              </a:lnSpc>
+              <a:buNone/>
+            </a:pPr>
+            <a:r>
+              <a:rPr lang="en-US" sz="2400" dirty="0"/>
+              <a:t>	Settings --&gt; Collaborators -&gt; Add People (next to Manage Access) </a:t>
+            </a:r>
+          </a:p>
+          <a:p>
+            <a:pPr marL="0" indent="0">
+              <a:buNone/>
+            </a:pPr>
+            <a:r>
+              <a:rPr lang="en-US" sz="3600" dirty="0"/>
+              <a:t>3. If you’re having trouble pushing to or pulling from GitHub, try authenticating again:</a:t>
+            </a:r>
+          </a:p>
+          <a:p>
+            <a:pPr marL="0" indent="0">
+              <a:lnSpc>
+                <a:spcPct val="200000"/>
+              </a:lnSpc>
+              <a:buNone/>
+            </a:pPr>
+            <a:r>
+              <a:rPr lang="en-US" sz="2400" dirty="0">
+                <a:latin typeface="Courier New"/>
+                <a:cs typeface="Courier New"/>
+              </a:rPr>
+              <a:t>	(</a:t>
+            </a:r>
+            <a:r>
+              <a:rPr lang="en-US" sz="2400" dirty="0" err="1">
+                <a:latin typeface="Courier New"/>
+                <a:cs typeface="Courier New"/>
+              </a:rPr>
+              <a:t>codeastro</a:t>
+            </a:r>
+            <a:r>
+              <a:rPr lang="en-US" sz="2400" dirty="0">
+                <a:latin typeface="Courier New"/>
+                <a:cs typeface="Courier New"/>
+              </a:rPr>
+              <a:t>) $ </a:t>
+            </a:r>
+            <a:r>
+              <a:rPr lang="en-US" sz="2400" dirty="0" err="1">
+                <a:latin typeface="Courier New"/>
+                <a:cs typeface="Courier New"/>
+              </a:rPr>
+              <a:t>gh</a:t>
+            </a:r>
+            <a:r>
+              <a:rPr lang="en-US" sz="2400" dirty="0">
+                <a:latin typeface="Courier New"/>
+                <a:cs typeface="Courier New"/>
+              </a:rPr>
+              <a:t> auth</a:t>
+            </a:r>
+          </a:p>
+        </p:txBody>
+      </p:sp>
+      <p:sp>
+        <p:nvSpPr>
+          <p:cNvPr id="5" name="TextBox 4">
+            <a:extLst>
+              <a:ext uri="{FF2B5EF4-FFF2-40B4-BE49-F238E27FC236}">
+                <a16:creationId xmlns:a16="http://schemas.microsoft.com/office/drawing/2014/main" id="{00EFA40D-D9BB-5D5B-1078-CC0BD962168F}"/>
+              </a:ext>
+            </a:extLst>
+          </p:cNvPr>
+          <p:cNvSpPr txBox="1"/>
+          <p:nvPr/>
+        </p:nvSpPr>
+        <p:spPr>
+          <a:xfrm>
+            <a:off x="1155701" y="13047193"/>
+            <a:ext cx="22694900" cy="523220"/>
+          </a:xfrm>
+          <a:prstGeom prst="rect">
+            <a:avLst/>
+          </a:prstGeom>
+          <a:noFill/>
+        </p:spPr>
+        <p:txBody>
+          <a:bodyPr wrap="square" rtlCol="0">
+            <a:spAutoFit/>
+          </a:bodyPr>
+          <a:lstStyle/>
+          <a:p>
+            <a:r>
+              <a:rPr lang="en-US" sz="2800" dirty="0"/>
+              <a:t>To see the demo again: https://</a:t>
+            </a:r>
+            <a:r>
+              <a:rPr lang="en-US" sz="2800" dirty="0" err="1"/>
+              <a:t>www.youtube.com</a:t>
+            </a:r>
+            <a:r>
+              <a:rPr lang="en-US" sz="2800" dirty="0"/>
+              <a:t>/</a:t>
+            </a:r>
+            <a:r>
+              <a:rPr lang="en-US" sz="2800" dirty="0" err="1"/>
+              <a:t>watch?v</a:t>
+            </a:r>
+            <a:r>
+              <a:rPr lang="en-US" sz="2800" dirty="0"/>
+              <a:t>=kWdzR41_qD0&amp;list=PLTNjIIFfMXAU7UgiTQLEm67j57zxwPmxN&amp;index=4</a:t>
+            </a:r>
           </a:p>
         </p:txBody>
       </p:sp>
     </p:spTree>
     <p:extLst>
       <p:ext uri="{BB962C8B-B14F-4D97-AF65-F5344CB8AC3E}">
-        <p14:creationId xmlns:p14="http://schemas.microsoft.com/office/powerpoint/2010/main" val="2031062326"/>
+        <p14:creationId xmlns:p14="http://schemas.microsoft.com/office/powerpoint/2010/main" val="2248961911"/>
       </p:ext>
     </p:extLst>
   </p:cSld>
@@ -14024,10 +14193,14 @@
               <a:buSzPts val="4000"/>
             </a:pPr>
             <a:r>
+              <a:rPr lang="en-US" sz="8000" dirty="0"/>
+              <a:t>Some Relevant Git </a:t>
+            </a:r>
+            <a:r>
               <a:rPr lang="en-US" sz="8000" dirty="0">
                 <a:latin typeface="+mn-lt"/>
               </a:rPr>
-              <a:t>Activities [15 mins]</a:t>
+              <a:t>Commands</a:t>
             </a:r>
             <a:endParaRPr dirty="0">
               <a:latin typeface="+mn-lt"/>
@@ -14047,8 +14220,8 @@
         </p:nvSpPr>
         <p:spPr>
           <a:xfrm>
-            <a:off x="533399" y="2055813"/>
-            <a:ext cx="23850601" cy="11660187"/>
+            <a:off x="1676399" y="3226709"/>
+            <a:ext cx="22326601" cy="8702676"/>
           </a:xfrm>
           <a:prstGeom prst="rect">
             <a:avLst/>
@@ -14060,7 +14233,7 @@
         </p:spPr>
         <p:txBody>
           <a:bodyPr spcFirstLastPara="1" wrap="square" lIns="182850" tIns="91400" rIns="182850" bIns="91400" anchor="t" anchorCtr="0">
-            <a:normAutofit fontScale="77500" lnSpcReduction="20000"/>
+            <a:normAutofit fontScale="92500" lnSpcReduction="10000"/>
           </a:bodyPr>
           <a:lstStyle/>
           <a:p>
@@ -14069,86 +14242,7 @@
                 <a:spcPct val="90000"/>
               </a:lnSpc>
               <a:spcBef>
-                <a:spcPts val="2000"/>
-              </a:spcBef>
-              <a:buClr>
-                <a:schemeClr val="dk1"/>
-              </a:buClr>
-              <a:buSzPct val="100000"/>
-              <a:buNone/>
-            </a:pPr>
-            <a:endParaRPr lang="en-US" dirty="0">
-              <a:latin typeface="Courier New"/>
-              <a:ea typeface="Courier New"/>
-              <a:cs typeface="Courier New"/>
-              <a:sym typeface="Courier New"/>
-            </a:endParaRPr>
-          </a:p>
-          <a:p>
-            <a:pPr marL="0" indent="0">
-              <a:lnSpc>
-                <a:spcPct val="90000"/>
-              </a:lnSpc>
-              <a:spcBef>
-                <a:spcPts val="2000"/>
-              </a:spcBef>
-              <a:buClr>
-                <a:schemeClr val="dk1"/>
-              </a:buClr>
-              <a:buSzPct val="100000"/>
-              <a:buNone/>
-            </a:pPr>
-            <a:r>
-              <a:rPr lang="en-US" dirty="0">
-                <a:latin typeface="+mn-lt"/>
-              </a:rPr>
-              <a:t>1. Make sure you can “git pull” the most recent version of the </a:t>
-            </a:r>
-            <a:r>
-              <a:rPr lang="en-US" dirty="0" err="1">
-                <a:latin typeface="+mn-lt"/>
-              </a:rPr>
-              <a:t>codeastro</a:t>
-            </a:r>
-            <a:r>
-              <a:rPr lang="en-US" dirty="0">
-                <a:latin typeface="+mn-lt"/>
-              </a:rPr>
-              <a:t> repo (main branch)</a:t>
-            </a:r>
-          </a:p>
-          <a:p>
-            <a:pPr marL="0" indent="0">
-              <a:lnSpc>
-                <a:spcPct val="90000"/>
-              </a:lnSpc>
-              <a:spcBef>
-                <a:spcPts val="2000"/>
-              </a:spcBef>
-              <a:buClr>
-                <a:schemeClr val="dk1"/>
-              </a:buClr>
-              <a:buSzPct val="100000"/>
-              <a:buNone/>
-            </a:pPr>
-            <a:r>
-              <a:rPr lang="en-US" dirty="0"/>
-              <a:t>	</a:t>
-            </a:r>
-            <a:r>
-              <a:rPr lang="en-US" sz="4400" dirty="0">
-                <a:latin typeface="+mn-lt"/>
-              </a:rPr>
-              <a:t>If you have local changes that you would like to save, you can do the following:</a:t>
-            </a:r>
-          </a:p>
-          <a:p>
-            <a:pPr marL="0" indent="0">
-              <a:lnSpc>
-                <a:spcPct val="90000"/>
-              </a:lnSpc>
-              <a:spcBef>
-                <a:spcPts val="2000"/>
+                <a:spcPts val="0"/>
               </a:spcBef>
               <a:buClr>
                 <a:schemeClr val="dk1"/>
@@ -14163,8 +14257,94 @@
                 <a:cs typeface="Courier New"/>
                 <a:sym typeface="Courier New"/>
               </a:rPr>
-              <a:t>	&gt; git stash</a:t>
+              <a:t>&gt; git checkout –b &lt;</a:t>
             </a:r>
+            <a:r>
+              <a:rPr lang="en-US" dirty="0" err="1">
+                <a:latin typeface="Courier New"/>
+                <a:ea typeface="Courier New"/>
+                <a:cs typeface="Courier New"/>
+                <a:sym typeface="Courier New"/>
+              </a:rPr>
+              <a:t>new_branch</a:t>
+            </a:r>
+            <a:r>
+              <a:rPr lang="en-US" dirty="0">
+                <a:latin typeface="Courier New"/>
+                <a:ea typeface="Courier New"/>
+                <a:cs typeface="Courier New"/>
+                <a:sym typeface="Courier New"/>
+              </a:rPr>
+              <a:t>&gt; &lt;</a:t>
+            </a:r>
+            <a:r>
+              <a:rPr lang="en-US" dirty="0" err="1">
+                <a:latin typeface="Courier New"/>
+                <a:ea typeface="Courier New"/>
+                <a:cs typeface="Courier New"/>
+                <a:sym typeface="Courier New"/>
+              </a:rPr>
+              <a:t>orig_branch</a:t>
+            </a:r>
+            <a:r>
+              <a:rPr lang="en-US" dirty="0">
+                <a:latin typeface="Courier New"/>
+                <a:ea typeface="Courier New"/>
+                <a:cs typeface="Courier New"/>
+                <a:sym typeface="Courier New"/>
+              </a:rPr>
+              <a:t>&gt; </a:t>
+            </a:r>
+            <a:endParaRPr lang="en-US" sz="4500" dirty="0"/>
+          </a:p>
+          <a:p>
+            <a:pPr marL="0" indent="0">
+              <a:lnSpc>
+                <a:spcPct val="90000"/>
+              </a:lnSpc>
+              <a:spcBef>
+                <a:spcPts val="2000"/>
+              </a:spcBef>
+              <a:buClr>
+                <a:schemeClr val="dk1"/>
+              </a:buClr>
+              <a:buSzPct val="100000"/>
+              <a:buNone/>
+            </a:pPr>
+            <a:r>
+              <a:rPr lang="en-US" sz="4500" dirty="0">
+                <a:latin typeface="+mn-lt"/>
+              </a:rPr>
+              <a:t>Make a new branch off of &lt;</a:t>
+            </a:r>
+            <a:r>
+              <a:rPr lang="en-US" sz="4500" dirty="0" err="1">
+                <a:latin typeface="+mn-lt"/>
+              </a:rPr>
+              <a:t>orig_branch</a:t>
+            </a:r>
+            <a:r>
+              <a:rPr lang="en-US" sz="4500" dirty="0">
+                <a:latin typeface="+mn-lt"/>
+              </a:rPr>
+              <a:t>&gt; (default: main)</a:t>
+            </a:r>
+          </a:p>
+          <a:p>
+            <a:pPr marL="0" indent="0">
+              <a:lnSpc>
+                <a:spcPct val="90000"/>
+              </a:lnSpc>
+              <a:spcBef>
+                <a:spcPts val="2000"/>
+              </a:spcBef>
+              <a:buClr>
+                <a:schemeClr val="dk1"/>
+              </a:buClr>
+              <a:buSzPct val="100000"/>
+              <a:buNone/>
+            </a:pPr>
+            <a:endParaRPr sz="4500" dirty="0"/>
           </a:p>
           <a:p>
             <a:pPr marL="0" indent="0">
@@ -14187,8 +14367,45 @@
                 <a:cs typeface="Courier New"/>
                 <a:sym typeface="Courier New"/>
               </a:rPr>
-              <a:t>	&gt; git pull origin main</a:t>
+              <a:t>&gt; git checkout &lt;branch&gt;</a:t>
             </a:r>
+          </a:p>
+          <a:p>
+            <a:pPr marL="0" indent="0">
+              <a:lnSpc>
+                <a:spcPct val="90000"/>
+              </a:lnSpc>
+              <a:spcBef>
+                <a:spcPts val="2000"/>
+              </a:spcBef>
+              <a:buClr>
+                <a:schemeClr val="dk1"/>
+              </a:buClr>
+              <a:buSzPct val="100000"/>
+              <a:buNone/>
+            </a:pPr>
+            <a:r>
+              <a:rPr lang="en-US" sz="4500" dirty="0">
+                <a:latin typeface="+mn-lt"/>
+              </a:rPr>
+              <a:t>Switch to desired branch</a:t>
+            </a:r>
+          </a:p>
+          <a:p>
+            <a:pPr marL="0" indent="0">
+              <a:lnSpc>
+                <a:spcPct val="90000"/>
+              </a:lnSpc>
+              <a:spcBef>
+                <a:spcPts val="2000"/>
+              </a:spcBef>
+              <a:buClr>
+                <a:schemeClr val="dk1"/>
+              </a:buClr>
+              <a:buSzPct val="100000"/>
+              <a:buNone/>
+            </a:pPr>
+            <a:endParaRPr lang="en-US" sz="4500" dirty="0"/>
           </a:p>
           <a:p>
             <a:pPr marL="0" indent="0">
@@ -14211,8 +14428,45 @@
                 <a:cs typeface="Courier New"/>
                 <a:sym typeface="Courier New"/>
               </a:rPr>
-              <a:t>	&gt; git stash pop</a:t>
+              <a:t>&gt; git branch -a</a:t>
             </a:r>
+          </a:p>
+          <a:p>
+            <a:pPr marL="0" indent="0">
+              <a:lnSpc>
+                <a:spcPct val="90000"/>
+              </a:lnSpc>
+              <a:spcBef>
+                <a:spcPts val="2000"/>
+              </a:spcBef>
+              <a:buClr>
+                <a:schemeClr val="dk1"/>
+              </a:buClr>
+              <a:buSzPct val="100000"/>
+              <a:buNone/>
+            </a:pPr>
+            <a:r>
+              <a:rPr lang="en-US" sz="4500" dirty="0">
+                <a:latin typeface="+mn-lt"/>
+              </a:rPr>
+              <a:t>List all available branches, highlighting the one you are currently on</a:t>
+            </a:r>
+          </a:p>
+          <a:p>
+            <a:pPr marL="0" indent="0">
+              <a:lnSpc>
+                <a:spcPct val="90000"/>
+              </a:lnSpc>
+              <a:spcBef>
+                <a:spcPts val="2000"/>
+              </a:spcBef>
+              <a:buClr>
+                <a:schemeClr val="dk1"/>
+              </a:buClr>
+              <a:buSzPct val="100000"/>
+              <a:buNone/>
+            </a:pPr>
+            <a:endParaRPr lang="en-US" sz="4500" dirty="0"/>
           </a:p>
           <a:p>
             <a:pPr marL="0" indent="0">
@@ -14230,66 +14484,34 @@
             </a:pPr>
             <a:r>
               <a:rPr lang="en-US" dirty="0">
-                <a:latin typeface="+mn-lt"/>
+                <a:latin typeface="Courier New"/>
                 <a:ea typeface="Courier New"/>
                 <a:cs typeface="Courier New"/>
                 <a:sym typeface="Courier New"/>
               </a:rPr>
-              <a:t>2. Within your project groups, create a repository (either a dummy repo or a repo for your project), and do the following:</a:t>
+              <a:t>&gt; git branch –d &lt;</a:t>
             </a:r>
-          </a:p>
-          <a:p>
-            <a:pPr marL="685800" indent="-685800">
-              <a:lnSpc>
-                <a:spcPct val="90000"/>
-              </a:lnSpc>
-              <a:spcBef>
-                <a:spcPts val="2000"/>
-              </a:spcBef>
-              <a:buClr>
-                <a:schemeClr val="dk1"/>
-              </a:buClr>
-              <a:buSzPct val="100000"/>
-              <a:buFont typeface="Arial" panose="020B0604020202020204" pitchFamily="34" charset="0"/>
-              <a:buChar char="•"/>
-            </a:pPr>
             <a:r>
-              <a:rPr lang="en-US" dirty="0">
-                <a:latin typeface="+mn-lt"/>
+              <a:rPr lang="en-US" dirty="0" err="1">
+                <a:latin typeface="Courier New"/>
                 <a:ea typeface="Courier New"/>
                 <a:cs typeface="Courier New"/>
                 <a:sym typeface="Courier New"/>
               </a:rPr>
-              <a:t>Create main, develop, and (at least) 2 feature branches.</a:t>
+              <a:t>branch_name</a:t>
             </a:r>
-          </a:p>
-          <a:p>
-            <a:pPr marL="685800" indent="-685800">
-              <a:lnSpc>
-                <a:spcPct val="90000"/>
-              </a:lnSpc>
-              <a:spcBef>
-                <a:spcPts val="2000"/>
-              </a:spcBef>
-              <a:buClr>
-                <a:schemeClr val="dk1"/>
-              </a:buClr>
-              <a:buSzPct val="100000"/>
-              <a:buFont typeface="Arial" panose="020B0604020202020204" pitchFamily="34" charset="0"/>
-              <a:buChar char="•"/>
-            </a:pPr>
             <a:r>
               <a:rPr lang="en-US" dirty="0">
-                <a:latin typeface="+mn-lt"/>
+                <a:latin typeface="Courier New"/>
                 <a:ea typeface="Courier New"/>
                 <a:cs typeface="Courier New"/>
                 <a:sym typeface="Courier New"/>
               </a:rPr>
-              <a:t>Raise an issue.</a:t>
+              <a:t>&gt;</a:t>
             </a:r>
           </a:p>
           <a:p>
-            <a:pPr marL="685800" indent="-685800">
+            <a:pPr marL="0" indent="0">
               <a:lnSpc>
                 <a:spcPct val="90000"/>
               </a:lnSpc>
@@ -14300,21 +14522,17 @@
                 <a:schemeClr val="dk1"/>
               </a:buClr>
               <a:buSzPct val="100000"/>
-              <a:buFont typeface="Arial" panose="020B0604020202020204" pitchFamily="34" charset="0"/>
-              <a:buChar char="•"/>
+              <a:buNone/>
             </a:pPr>
             <a:r>
-              <a:rPr lang="en-US" dirty="0">
+              <a:rPr lang="en-US" sz="4500" dirty="0">
                 <a:latin typeface="+mn-lt"/>
-                <a:ea typeface="Courier New"/>
-                <a:cs typeface="Courier New"/>
-                <a:sym typeface="Courier New"/>
               </a:rPr>
-              <a:t>Clone the repo to your machine, make changes on each of the feature branches, and open pull requests to merge them into main.</a:t>
+              <a:t>Delete a branch from your local repo</a:t>
             </a:r>
           </a:p>
           <a:p>
-            <a:pPr marL="685800" indent="-685800">
+            <a:pPr marL="0" indent="0">
               <a:lnSpc>
                 <a:spcPct val="90000"/>
               </a:lnSpc>
@@ -14325,57 +14543,132 @@
                 <a:schemeClr val="dk1"/>
               </a:buClr>
               <a:buSzPct val="100000"/>
-              <a:buFont typeface="Arial" panose="020B0604020202020204" pitchFamily="34" charset="0"/>
-              <a:buChar char="•"/>
+              <a:buNone/>
             </a:pPr>
-            <a:r>
-              <a:rPr lang="en-US" dirty="0">
-                <a:latin typeface="+mn-lt"/>
-                <a:ea typeface="Courier New"/>
-                <a:cs typeface="Courier New"/>
-                <a:sym typeface="Courier New"/>
-              </a:rPr>
-              <a:t>Perform the merges.</a:t>
-            </a:r>
-          </a:p>
-          <a:p>
-            <a:pPr marL="0" indent="0">
-              <a:buNone/>
-            </a:pPr>
-            <a:r>
-              <a:rPr lang="en-US" sz="5400" dirty="0"/>
-              <a:t>NOTE: To push to the same repository, the repository creator will need to add others as collaborators. To do this from the repo’s homepage:</a:t>
-            </a:r>
-          </a:p>
-          <a:p>
-            <a:pPr marL="0" indent="0">
-              <a:buNone/>
-            </a:pPr>
-            <a:r>
-              <a:rPr lang="en-US" sz="5400" dirty="0"/>
-              <a:t>Settings -&gt; Collaborators -&gt; Add People (next to Manage Access) </a:t>
-            </a:r>
-          </a:p>
-          <a:p>
-            <a:pPr marL="685800" indent="-685800">
-              <a:lnSpc>
-                <a:spcPct val="90000"/>
-              </a:lnSpc>
-              <a:spcBef>
-                <a:spcPts val="2000"/>
-              </a:spcBef>
-              <a:buClr>
-                <a:schemeClr val="dk1"/>
-              </a:buClr>
-              <a:buSzPct val="100000"/>
-              <a:buFont typeface="Arial" panose="020B0604020202020204" pitchFamily="34" charset="0"/>
-              <a:buChar char="•"/>
-            </a:pPr>
-            <a:endParaRPr dirty="0">
-              <a:latin typeface="+mn-lt"/>
+            <a:endParaRPr lang="en-US" dirty="0">
+              <a:latin typeface="Courier New"/>
               <a:ea typeface="Courier New"/>
               <a:cs typeface="Courier New"/>
               <a:sym typeface="Courier New"/>
+            </a:endParaRPr>
+          </a:p>
+          <a:p>
+            <a:pPr indent="-457200">
+              <a:lnSpc>
+                <a:spcPct val="90000"/>
+              </a:lnSpc>
+              <a:spcBef>
+                <a:spcPts val="2000"/>
+              </a:spcBef>
+              <a:buClr>
+                <a:schemeClr val="dk1"/>
+              </a:buClr>
+              <a:buSzPct val="100000"/>
+            </a:pPr>
+            <a:endParaRPr dirty="0"/>
+          </a:p>
+          <a:p>
+            <a:pPr marL="0" indent="0">
+              <a:lnSpc>
+                <a:spcPct val="90000"/>
+              </a:lnSpc>
+              <a:spcBef>
+                <a:spcPts val="2000"/>
+              </a:spcBef>
+              <a:buClr>
+                <a:schemeClr val="dk1"/>
+              </a:buClr>
+              <a:buSzPct val="100000"/>
+              <a:buNone/>
+            </a:pPr>
+            <a:endParaRPr dirty="0">
+              <a:latin typeface="Courier New"/>
+              <a:ea typeface="Courier New"/>
+              <a:cs typeface="Courier New"/>
+              <a:sym typeface="Courier New"/>
+            </a:endParaRPr>
+          </a:p>
+        </p:txBody>
+      </p:sp>
+      <p:sp>
+        <p:nvSpPr>
+          <p:cNvPr id="99" name="Google Shape;99;p3"/>
+          <p:cNvSpPr txBox="1"/>
+          <p:nvPr/>
+        </p:nvSpPr>
+        <p:spPr>
+          <a:xfrm>
+            <a:off x="0" y="12603390"/>
+            <a:ext cx="25117676" cy="1046360"/>
+          </a:xfrm>
+          <a:prstGeom prst="rect">
+            <a:avLst/>
+          </a:prstGeom>
+          <a:noFill/>
+          <a:ln>
+            <a:noFill/>
+          </a:ln>
+        </p:spPr>
+        <p:txBody>
+          <a:bodyPr spcFirstLastPara="1" wrap="square" lIns="182850" tIns="91400" rIns="182850" bIns="91400" anchor="t" anchorCtr="0">
+            <a:spAutoFit/>
+          </a:bodyPr>
+          <a:lstStyle/>
+          <a:p>
+            <a:pPr algn="ctr"/>
+            <a:r>
+              <a:rPr lang="en-US" sz="3200" dirty="0">
+                <a:solidFill>
+                  <a:schemeClr val="dk1"/>
+                </a:solidFill>
+                <a:latin typeface="+mn-lt"/>
+                <a:ea typeface="Calibri"/>
+                <a:cs typeface="Calibri"/>
+                <a:sym typeface="Calibri"/>
+              </a:rPr>
+              <a:t>There are a lot of “Git cheat sheets” online if you want a summary of more commands! Here’s the one I have bookmarked:</a:t>
+            </a:r>
+          </a:p>
+          <a:p>
+            <a:pPr algn="ctr"/>
+            <a:r>
+              <a:rPr lang="en-US" sz="2400" dirty="0">
+                <a:latin typeface="+mn-lt"/>
+              </a:rPr>
+              <a:t>https://</a:t>
+            </a:r>
+            <a:r>
+              <a:rPr lang="en-US" sz="2400" dirty="0" err="1">
+                <a:latin typeface="+mn-lt"/>
+              </a:rPr>
+              <a:t>training.github.com</a:t>
+            </a:r>
+            <a:r>
+              <a:rPr lang="en-US" sz="2400" dirty="0">
+                <a:latin typeface="+mn-lt"/>
+              </a:rPr>
+              <a:t>/downloads/</a:t>
+            </a:r>
+            <a:r>
+              <a:rPr lang="en-US" sz="2400" dirty="0" err="1">
+                <a:latin typeface="+mn-lt"/>
+              </a:rPr>
+              <a:t>github</a:t>
+            </a:r>
+            <a:r>
+              <a:rPr lang="en-US" sz="2400" dirty="0">
+                <a:latin typeface="+mn-lt"/>
+              </a:rPr>
+              <a:t>-git-cheat-</a:t>
+            </a:r>
+            <a:r>
+              <a:rPr lang="en-US" sz="2400" dirty="0" err="1">
+                <a:latin typeface="+mn-lt"/>
+              </a:rPr>
+              <a:t>sheet.pdf</a:t>
+            </a:r>
+            <a:endParaRPr sz="2400" dirty="0">
+              <a:latin typeface="+mn-lt"/>
             </a:endParaRPr>
           </a:p>
         </p:txBody>
@@ -14383,7 +14676,7 @@
     </p:spTree>
     <p:extLst>
       <p:ext uri="{BB962C8B-B14F-4D97-AF65-F5344CB8AC3E}">
-        <p14:creationId xmlns:p14="http://schemas.microsoft.com/office/powerpoint/2010/main" val="2248961911"/>
+        <p14:creationId xmlns:p14="http://schemas.microsoft.com/office/powerpoint/2010/main" val="2031062326"/>
       </p:ext>
     </p:extLst>
   </p:cSld>

</xml_diff>